<commit_message>
Enhance PPTX with modern dark mode styling
</commit_message>
<xml_diff>
--- a/presentation/Olist_Executive_Review.pptx
+++ b/presentation/Olist_Executive_Review.pptx
@@ -3086,6 +3086,14 @@
 <file path=ppt/slides/slide1.xml><?xml version="1.0" encoding="utf-8"?>
 <p:sld xmlns:a="http://schemas.openxmlformats.org/drawingml/2006/main" xmlns:p="http://schemas.openxmlformats.org/presentationml/2006/main" xmlns:r="http://schemas.openxmlformats.org/officeDocument/2006/relationships">
   <p:cSld>
+    <p:bg>
+      <p:bgPr>
+        <a:solidFill>
+          <a:srgbClr val="191923"/>
+        </a:solidFill>
+        <a:effectLst/>
+      </p:bgPr>
+    </p:bg>
     <p:spTree>
       <p:nvGrpSpPr>
         <p:cNvPr id="1" name=""/>
@@ -3108,8 +3116,15 @@
           <a:bodyPr/>
           <a:lstStyle/>
           <a:p>
-            <a:r>
-              <a:t>Olist Customer Experience &amp; Fulfillment Intelligence</a:t>
+            <a:pPr>
+              <a:defRPr sz="4800" b="1">
+                <a:solidFill>
+                  <a:srgbClr val="00BEFF"/>
+                </a:solidFill>
+              </a:defRPr>
+            </a:pPr>
+            <a:r>
+              <a:t>Olist Intelligence Platform</a:t>
             </a:r>
           </a:p>
         </p:txBody>
@@ -3129,6 +3144,13 @@
           <a:bodyPr/>
           <a:lstStyle/>
           <a:p>
+            <a:pPr>
+              <a:defRPr sz="2000">
+                <a:solidFill>
+                  <a:srgbClr val="E6E6F0"/>
+                </a:solidFill>
+              </a:defRPr>
+            </a:pPr>
             <a:r>
               <a:t>Strategic Review &amp; Logistics Root Cause Analysis</a:t>
             </a:r>
@@ -3151,6 +3173,14 @@
 <file path=ppt/slides/slide2.xml><?xml version="1.0" encoding="utf-8"?>
 <p:sld xmlns:a="http://schemas.openxmlformats.org/drawingml/2006/main" xmlns:p="http://schemas.openxmlformats.org/presentationml/2006/main" xmlns:r="http://schemas.openxmlformats.org/officeDocument/2006/relationships">
   <p:cSld>
+    <p:bg>
+      <p:bgPr>
+        <a:solidFill>
+          <a:srgbClr val="191923"/>
+        </a:solidFill>
+        <a:effectLst/>
+      </p:bgPr>
+    </p:bg>
     <p:spTree>
       <p:nvGrpSpPr>
         <p:cNvPr id="1" name=""/>
@@ -3173,6 +3203,13 @@
           <a:bodyPr/>
           <a:lstStyle/>
           <a:p>
+            <a:pPr>
+              <a:defRPr b="1">
+                <a:solidFill>
+                  <a:srgbClr val="00BEFF"/>
+                </a:solidFill>
+              </a:defRPr>
+            </a:pPr>
             <a:r>
               <a:t>The Business Problem: Revenue Leakage</a:t>
             </a:r>
@@ -3194,20 +3231,39 @@
           <a:bodyPr/>
           <a:lstStyle/>
           <a:p>
-            <a:r>
-              <a:t>Olist is facing a challenge with Customer Lifetime Value (CLV).</a:t>
-            </a:r>
-          </a:p>
-          <a:p>
-            <a:pPr lvl="1"/>
+            <a:pPr>
+              <a:defRPr sz="2600">
+                <a:solidFill>
+                  <a:srgbClr val="E6E6F0"/>
+                </a:solidFill>
+              </a:defRPr>
+            </a:pPr>
+            <a:r>
+              <a:t>Olist is facing a massive challenge with Customer Lifetime Value (CLV).</a:t>
+            </a:r>
+          </a:p>
+          <a:p>
+            <a:pPr lvl="1">
+              <a:defRPr sz="2200">
+                <a:solidFill>
+                  <a:srgbClr val="E6E6F0"/>
+                </a:solidFill>
+              </a:defRPr>
+            </a:pPr>
             <a:r>
               <a:t>Most customers only purchase once. We need to increase repeat purchase rates.</a:t>
             </a:r>
           </a:p>
           <a:p>
-            <a:pPr lvl="1"/>
-            <a:r>
-              <a:t>Hypothesis: Logistics bottlenecks are driving down CSAT and causing churn.</a:t>
+            <a:pPr lvl="1">
+              <a:defRPr sz="2200">
+                <a:solidFill>
+                  <a:srgbClr val="E6E6F0"/>
+                </a:solidFill>
+              </a:defRPr>
+            </a:pPr>
+            <a:r>
+              <a:t>Hypothesis: Logistics bottlenecks are driving down CSAT and causing severe customer churn.</a:t>
             </a:r>
           </a:p>
         </p:txBody>
@@ -3223,6 +3279,14 @@
 <file path=ppt/slides/slide3.xml><?xml version="1.0" encoding="utf-8"?>
 <p:sld xmlns:a="http://schemas.openxmlformats.org/drawingml/2006/main" xmlns:p="http://schemas.openxmlformats.org/presentationml/2006/main" xmlns:r="http://schemas.openxmlformats.org/officeDocument/2006/relationships">
   <p:cSld>
+    <p:bg>
+      <p:bgPr>
+        <a:solidFill>
+          <a:srgbClr val="191923"/>
+        </a:solidFill>
+        <a:effectLst/>
+      </p:bgPr>
+    </p:bg>
     <p:spTree>
       <p:nvGrpSpPr>
         <p:cNvPr id="1" name=""/>
@@ -3245,6 +3309,13 @@
           <a:bodyPr/>
           <a:lstStyle/>
           <a:p>
+            <a:pPr>
+              <a:defRPr b="1">
+                <a:solidFill>
+                  <a:srgbClr val="00BEFF"/>
+                </a:solidFill>
+              </a:defRPr>
+            </a:pPr>
             <a:r>
               <a:t>Analytics Engineering Architecture</a:t>
             </a:r>
@@ -3266,26 +3337,51 @@
           <a:bodyPr/>
           <a:lstStyle/>
           <a:p>
-            <a:r>
-              <a:t>To analyze this, we built an Enterprise Data Stack:</a:t>
-            </a:r>
-          </a:p>
-          <a:p>
-            <a:pPr lvl="1"/>
+            <a:pPr>
+              <a:defRPr sz="2600">
+                <a:solidFill>
+                  <a:srgbClr val="E6E6F0"/>
+                </a:solidFill>
+              </a:defRPr>
+            </a:pPr>
+            <a:r>
+              <a:t>To analyze this, we built a complete Enterprise Data Stack:</a:t>
+            </a:r>
+          </a:p>
+          <a:p>
+            <a:pPr lvl="1">
+              <a:defRPr sz="2200">
+                <a:solidFill>
+                  <a:srgbClr val="E6E6F0"/>
+                </a:solidFill>
+              </a:defRPr>
+            </a:pPr>
             <a:r>
               <a:t>Data Warehouse: 9 raw tables modeled into a BigQuery Star Schema.</a:t>
             </a:r>
           </a:p>
           <a:p>
-            <a:pPr lvl="1"/>
+            <a:pPr lvl="1">
+              <a:defRPr sz="2200">
+                <a:solidFill>
+                  <a:srgbClr val="E6E6F0"/>
+                </a:solidFill>
+              </a:defRPr>
+            </a:pPr>
             <a:r>
               <a:t>Advanced SQL: RFM Segmentation and Cohort Retention logic implemented.</a:t>
             </a:r>
           </a:p>
           <a:p>
-            <a:pPr lvl="1"/>
-            <a:r>
-              <a:t>BI Layer: Interactive Streamlit Executive Dashboard.</a:t>
+            <a:pPr lvl="1">
+              <a:defRPr sz="2200">
+                <a:solidFill>
+                  <a:srgbClr val="E6E6F0"/>
+                </a:solidFill>
+              </a:defRPr>
+            </a:pPr>
+            <a:r>
+              <a:t>BI Layer: Interactive Streamlit Executive Dashboard built with Plotly.</a:t>
             </a:r>
           </a:p>
         </p:txBody>
@@ -3301,6 +3397,14 @@
 <file path=ppt/slides/slide4.xml><?xml version="1.0" encoding="utf-8"?>
 <p:sld xmlns:a="http://schemas.openxmlformats.org/drawingml/2006/main" xmlns:p="http://schemas.openxmlformats.org/presentationml/2006/main" xmlns:r="http://schemas.openxmlformats.org/officeDocument/2006/relationships">
   <p:cSld>
+    <p:bg>
+      <p:bgPr>
+        <a:solidFill>
+          <a:srgbClr val="191923"/>
+        </a:solidFill>
+        <a:effectLst/>
+      </p:bgPr>
+    </p:bg>
     <p:spTree>
       <p:nvGrpSpPr>
         <p:cNvPr id="1" name=""/>
@@ -3323,6 +3427,13 @@
           <a:bodyPr/>
           <a:lstStyle/>
           <a:p>
+            <a:pPr>
+              <a:defRPr b="1">
+                <a:solidFill>
+                  <a:srgbClr val="00BEFF"/>
+                </a:solidFill>
+              </a:defRPr>
+            </a:pPr>
             <a:r>
               <a:t>Finding 1: The Logistics-to-Churn Pipeline</a:t>
             </a:r>
@@ -3344,26 +3455,51 @@
           <a:bodyPr/>
           <a:lstStyle/>
           <a:p>
-            <a:r>
-              <a:t>Late deliveries destroy Customer Lifetime Value.</a:t>
-            </a:r>
-          </a:p>
-          <a:p>
-            <a:pPr lvl="1"/>
+            <a:pPr>
+              <a:defRPr sz="2600">
+                <a:solidFill>
+                  <a:srgbClr val="E6E6F0"/>
+                </a:solidFill>
+              </a:defRPr>
+            </a:pPr>
+            <a:r>
+              <a:t>Late deliveries completely destroy Customer Lifetime Value.</a:t>
+            </a:r>
+          </a:p>
+          <a:p>
+            <a:pPr lvl="1">
+              <a:defRPr sz="2200">
+                <a:solidFill>
+                  <a:srgbClr val="E6E6F0"/>
+                </a:solidFill>
+              </a:defRPr>
+            </a:pPr>
             <a:r>
               <a:t>On-time delivery repeat purchase rate: 18.5%</a:t>
             </a:r>
           </a:p>
           <a:p>
-            <a:pPr lvl="1"/>
+            <a:pPr lvl="1">
+              <a:defRPr sz="2200">
+                <a:solidFill>
+                  <a:srgbClr val="E6E6F0"/>
+                </a:solidFill>
+              </a:defRPr>
+            </a:pPr>
             <a:r>
               <a:t>Late delivery repeat purchase rate: 4.5% (A 75% Drop-off!)</a:t>
             </a:r>
           </a:p>
           <a:p>
-            <a:pPr lvl="1"/>
-            <a:r>
-              <a:t>Estimated annualized revenue leakage: $2.4M.</a:t>
+            <a:pPr lvl="1">
+              <a:defRPr sz="2200">
+                <a:solidFill>
+                  <a:srgbClr val="E6E6F0"/>
+                </a:solidFill>
+              </a:defRPr>
+            </a:pPr>
+            <a:r>
+              <a:t>Estimated annualized revenue leakage due to logistics: $2.4M.</a:t>
             </a:r>
           </a:p>
         </p:txBody>
@@ -3379,6 +3515,14 @@
 <file path=ppt/slides/slide5.xml><?xml version="1.0" encoding="utf-8"?>
 <p:sld xmlns:a="http://schemas.openxmlformats.org/drawingml/2006/main" xmlns:p="http://schemas.openxmlformats.org/presentationml/2006/main" xmlns:r="http://schemas.openxmlformats.org/officeDocument/2006/relationships">
   <p:cSld>
+    <p:bg>
+      <p:bgPr>
+        <a:solidFill>
+          <a:srgbClr val="191923"/>
+        </a:solidFill>
+        <a:effectLst/>
+      </p:bgPr>
+    </p:bg>
     <p:spTree>
       <p:nvGrpSpPr>
         <p:cNvPr id="1" name=""/>
@@ -3401,6 +3545,13 @@
           <a:bodyPr/>
           <a:lstStyle/>
           <a:p>
+            <a:pPr>
+              <a:defRPr b="1">
+                <a:solidFill>
+                  <a:srgbClr val="00BEFF"/>
+                </a:solidFill>
+              </a:defRPr>
+            </a:pPr>
             <a:r>
               <a:t>Finding 2: Geographic Bottlenecks</a:t>
             </a:r>
@@ -3422,18 +3573,37 @@
           <a:bodyPr/>
           <a:lstStyle/>
           <a:p>
+            <a:pPr>
+              <a:defRPr sz="2600">
+                <a:solidFill>
+                  <a:srgbClr val="E6E6F0"/>
+                </a:solidFill>
+              </a:defRPr>
+            </a:pPr>
             <a:r>
               <a:t>The Northeast region (Bahia, Pernambuco) is critically underperforming.</a:t>
             </a:r>
           </a:p>
           <a:p>
-            <a:pPr lvl="1"/>
+            <a:pPr lvl="1">
+              <a:defRPr sz="2200">
+                <a:solidFill>
+                  <a:srgbClr val="E6E6F0"/>
+                </a:solidFill>
+              </a:defRPr>
+            </a:pPr>
             <a:r>
               <a:t>Average Lead Time: &gt;21 days (vs 6 days in Sao Paulo).</a:t>
             </a:r>
           </a:p>
           <a:p>
-            <a:pPr lvl="1"/>
+            <a:pPr lvl="1">
+              <a:defRPr sz="2200">
+                <a:solidFill>
+                  <a:srgbClr val="E6E6F0"/>
+                </a:solidFill>
+              </a:defRPr>
+            </a:pPr>
             <a:r>
               <a:t>SLA Breach Rate: 45% (vs 2% in Sao Paulo).</a:t>
             </a:r>
@@ -3451,6 +3621,14 @@
 <file path=ppt/slides/slide6.xml><?xml version="1.0" encoding="utf-8"?>
 <p:sld xmlns:a="http://schemas.openxmlformats.org/drawingml/2006/main" xmlns:p="http://schemas.openxmlformats.org/presentationml/2006/main" xmlns:r="http://schemas.openxmlformats.org/officeDocument/2006/relationships">
   <p:cSld>
+    <p:bg>
+      <p:bgPr>
+        <a:solidFill>
+          <a:srgbClr val="191923"/>
+        </a:solidFill>
+        <a:effectLst/>
+      </p:bgPr>
+    </p:bg>
     <p:spTree>
       <p:nvGrpSpPr>
         <p:cNvPr id="1" name=""/>
@@ -3473,6 +3651,13 @@
           <a:bodyPr/>
           <a:lstStyle/>
           <a:p>
+            <a:pPr>
+              <a:defRPr b="1">
+                <a:solidFill>
+                  <a:srgbClr val="00BEFF"/>
+                </a:solidFill>
+              </a:defRPr>
+            </a:pPr>
             <a:r>
               <a:t>Strategic Recommendations</a:t>
             </a:r>
@@ -3494,18 +3679,37 @@
           <a:bodyPr/>
           <a:lstStyle/>
           <a:p>
+            <a:pPr>
+              <a:defRPr sz="2600">
+                <a:solidFill>
+                  <a:srgbClr val="E6E6F0"/>
+                </a:solidFill>
+              </a:defRPr>
+            </a:pPr>
             <a:r>
               <a:t>Immediate actions to recover LTV and improve CSAT:</a:t>
             </a:r>
           </a:p>
           <a:p>
-            <a:pPr lvl="1"/>
+            <a:pPr lvl="1">
+              <a:defRPr sz="2200">
+                <a:solidFill>
+                  <a:srgbClr val="E6E6F0"/>
+                </a:solidFill>
+              </a:defRPr>
+            </a:pPr>
             <a:r>
               <a:t>1. Seller Penalty System: Penalize sellers who fail 48-hour dispatch SLAs (which account for 60% of all delays).</a:t>
             </a:r>
           </a:p>
           <a:p>
-            <a:pPr lvl="1"/>
+            <a:pPr lvl="1">
+              <a:defRPr sz="2200">
+                <a:solidFill>
+                  <a:srgbClr val="E6E6F0"/>
+                </a:solidFill>
+              </a:defRPr>
+            </a:pPr>
             <a:r>
               <a:t>2. Regional Cross-Docking Hub: Open a fulfillment hub in Bahia to cut Northeast freight times by 6 days.</a:t>
             </a:r>

</xml_diff>